<commit_message>
fix(pptx): corriger feuille de route — déplacer features livrées
Tableau de bord enrichi et Webhooks fraude sont maintenant terminés.
Nouvelle structure roadmap :
  - Colonne "Livré ✅" : dashboard KPIs, webhooks auto, SSE, dark mode
  - Colonne "Q3 2026" : API Keys UI, dashboard multi-tenant, SHAP
  - Colonne "Q4 2026" : IA v2, SWIFT, mobile, ISO 27001

Co-Authored-By: Claude Sonnet 4.6 <noreply@anthropic.com>
</commit_message>
<xml_diff>
--- a/pptx/FraudGuard_Presentation.pptx
+++ b/pptx/FraudGuard_Presentation.pptx
@@ -10855,6 +10855,401 @@
             </a:avLst>
           </a:prstGeom>
           <a:solidFill>
+            <a:srgbClr val="10B981"/>
+          </a:solidFill>
+          <a:ln w="12700">
+            <a:solidFill>
+              <a:srgbClr val="10B981"/>
+            </a:solidFill>
+            <a:prstDash val="solid"/>
+          </a:ln>
+        </p:spPr>
+      </p:sp>
+      <p:sp>
+        <p:nvSpPr>
+          <p:cNvPr id="6" name="Text 4"/>
+          <p:cNvSpPr/>
+          <p:nvPr/>
+        </p:nvSpPr>
+        <p:spPr>
+          <a:xfrm>
+            <a:off x="777240" y="1417320"/>
+            <a:ext cx="1828800" cy="347472"/>
+          </a:xfrm>
+          <a:prstGeom prst="rect">
+            <a:avLst/>
+          </a:prstGeom>
+          <a:noFill/>
+          <a:ln/>
+        </p:spPr>
+        <p:txBody>
+          <a:bodyPr wrap="square" lIns="0" tIns="0" rIns="0" bIns="0" rtlCol="0" anchor="ctr"/>
+          <a:lstStyle/>
+          <a:p>
+            <a:pPr algn="ctr" indent="0" marL="0">
+              <a:buNone/>
+            </a:pPr>
+            <a:r>
+              <a:rPr lang="en-US" sz="1100" b="1" dirty="0">
+                <a:solidFill>
+                  <a:srgbClr val="FFFFFF"/>
+                </a:solidFill>
+                <a:latin typeface="Calibri" pitchFamily="34" charset="0"/>
+                <a:ea typeface="Calibri" pitchFamily="34" charset="-122"/>
+                <a:cs typeface="Calibri" pitchFamily="34" charset="-120"/>
+              </a:rPr>
+              <a:t>✅ Terminé</a:t>
+            </a:r>
+            <a:endParaRPr lang="en-US" sz="1100" dirty="0"/>
+          </a:p>
+        </p:txBody>
+      </p:sp>
+      <p:sp>
+        <p:nvSpPr>
+          <p:cNvPr id="7" name="Text 5"/>
+          <p:cNvSpPr/>
+          <p:nvPr/>
+        </p:nvSpPr>
+        <p:spPr>
+          <a:xfrm>
+            <a:off x="320040" y="1874520"/>
+            <a:ext cx="2743200" cy="475488"/>
+          </a:xfrm>
+          <a:prstGeom prst="rect">
+            <a:avLst/>
+          </a:prstGeom>
+          <a:noFill/>
+          <a:ln/>
+        </p:spPr>
+        <p:txBody>
+          <a:bodyPr wrap="square" lIns="0" tIns="0" rIns="0" bIns="0" rtlCol="0" anchor="ctr"/>
+          <a:lstStyle/>
+          <a:p>
+            <a:pPr algn="ctr" indent="0" marL="0">
+              <a:buNone/>
+            </a:pPr>
+            <a:r>
+              <a:rPr lang="en-US" sz="2800" b="1" dirty="0">
+                <a:solidFill>
+                  <a:srgbClr val="10B981"/>
+                </a:solidFill>
+                <a:latin typeface="Cambria" pitchFamily="34" charset="0"/>
+                <a:ea typeface="Cambria" pitchFamily="34" charset="-122"/>
+                <a:cs typeface="Cambria" pitchFamily="34" charset="-120"/>
+              </a:rPr>
+              <a:t>Livré</a:t>
+            </a:r>
+            <a:endParaRPr lang="en-US" sz="2800" dirty="0"/>
+          </a:p>
+        </p:txBody>
+      </p:sp>
+      <p:sp>
+        <p:nvSpPr>
+          <p:cNvPr id="8" name="Shape 6"/>
+          <p:cNvSpPr/>
+          <p:nvPr/>
+        </p:nvSpPr>
+        <p:spPr>
+          <a:xfrm>
+            <a:off x="320040" y="2450592"/>
+            <a:ext cx="2788920" cy="2514600"/>
+          </a:xfrm>
+          <a:prstGeom prst="rect">
+            <a:avLst>
+              <a:gd name="adj" fmla="val 3636"/>
+            </a:avLst>
+          </a:prstGeom>
+          <a:solidFill>
+            <a:srgbClr val="FFFFFF"/>
+          </a:solidFill>
+          <a:ln w="12700">
+            <a:solidFill>
+              <a:srgbClr val="10B981"/>
+            </a:solidFill>
+            <a:prstDash val="solid"/>
+          </a:ln>
+          <a:effectLst>
+            <a:outerShdw sx="100000" sy="100000" kx="0" ky="0" algn="bl" rotWithShape="0" blurRad="101600" dist="38100" dir="2700000">
+              <a:srgbClr val="000000">
+                <a:alpha val="12000"/>
+              </a:srgbClr>
+            </a:outerShdw>
+          </a:effectLst>
+        </p:spPr>
+      </p:sp>
+      <p:sp>
+        <p:nvSpPr>
+          <p:cNvPr id="9" name="Shape 7"/>
+          <p:cNvSpPr/>
+          <p:nvPr/>
+        </p:nvSpPr>
+        <p:spPr>
+          <a:xfrm>
+            <a:off x="502920" y="2679192"/>
+            <a:ext cx="256032" cy="256032"/>
+          </a:xfrm>
+          <a:prstGeom prst="ellipse">
+            <a:avLst/>
+          </a:prstGeom>
+          <a:solidFill>
+            <a:srgbClr val="10B981"/>
+          </a:solidFill>
+          <a:ln w="12700">
+            <a:solidFill>
+              <a:srgbClr val="10B981"/>
+            </a:solidFill>
+            <a:prstDash val="solid"/>
+          </a:ln>
+        </p:spPr>
+      </p:sp>
+      <p:sp>
+        <p:nvSpPr>
+          <p:cNvPr id="10" name="Text 8"/>
+          <p:cNvSpPr/>
+          <p:nvPr/>
+        </p:nvSpPr>
+        <p:spPr>
+          <a:xfrm>
+            <a:off x="850392" y="2606040"/>
+            <a:ext cx="2148840" cy="457200"/>
+          </a:xfrm>
+          <a:prstGeom prst="rect">
+            <a:avLst/>
+          </a:prstGeom>
+          <a:noFill/>
+          <a:ln/>
+        </p:spPr>
+        <p:txBody>
+          <a:bodyPr wrap="square" lIns="0" tIns="0" rIns="0" bIns="0" rtlCol="0" anchor="ctr"/>
+          <a:lstStyle/>
+          <a:p>
+            <a:pPr indent="0" marL="0">
+              <a:buNone/>
+            </a:pPr>
+            <a:r>
+              <a:rPr lang="en-US" sz="1100" dirty="0">
+                <a:solidFill>
+                  <a:srgbClr val="1E3A5F"/>
+                </a:solidFill>
+                <a:latin typeface="Calibri" pitchFamily="34" charset="0"/>
+                <a:ea typeface="Calibri" pitchFamily="34" charset="-122"/>
+                <a:cs typeface="Calibri" pitchFamily="34" charset="-120"/>
+              </a:rPr>
+              <a:t>Tableau de bord enrichi — KPIs réels &amp; graphiques avancés</a:t>
+            </a:r>
+            <a:endParaRPr lang="en-US" sz="1100" dirty="0"/>
+          </a:p>
+        </p:txBody>
+      </p:sp>
+      <p:sp>
+        <p:nvSpPr>
+          <p:cNvPr id="11" name="Shape 9"/>
+          <p:cNvSpPr/>
+          <p:nvPr/>
+        </p:nvSpPr>
+        <p:spPr>
+          <a:xfrm>
+            <a:off x="502920" y="3246120"/>
+            <a:ext cx="256032" cy="256032"/>
+          </a:xfrm>
+          <a:prstGeom prst="ellipse">
+            <a:avLst/>
+          </a:prstGeom>
+          <a:solidFill>
+            <a:srgbClr val="10B981"/>
+          </a:solidFill>
+          <a:ln w="12700">
+            <a:solidFill>
+              <a:srgbClr val="10B981"/>
+            </a:solidFill>
+            <a:prstDash val="solid"/>
+          </a:ln>
+        </p:spPr>
+      </p:sp>
+      <p:sp>
+        <p:nvSpPr>
+          <p:cNvPr id="12" name="Text 10"/>
+          <p:cNvSpPr/>
+          <p:nvPr/>
+        </p:nvSpPr>
+        <p:spPr>
+          <a:xfrm>
+            <a:off x="850392" y="3172968"/>
+            <a:ext cx="2148840" cy="457200"/>
+          </a:xfrm>
+          <a:prstGeom prst="rect">
+            <a:avLst/>
+          </a:prstGeom>
+          <a:noFill/>
+          <a:ln/>
+        </p:spPr>
+        <p:txBody>
+          <a:bodyPr wrap="square" lIns="0" tIns="0" rIns="0" bIns="0" rtlCol="0" anchor="ctr"/>
+          <a:lstStyle/>
+          <a:p>
+            <a:pPr indent="0" marL="0">
+              <a:buNone/>
+            </a:pPr>
+            <a:r>
+              <a:rPr lang="en-US" sz="1100" dirty="0">
+                <a:solidFill>
+                  <a:srgbClr val="1E3A5F"/>
+                </a:solidFill>
+                <a:latin typeface="Calibri" pitchFamily="34" charset="0"/>
+                <a:ea typeface="Calibri" pitchFamily="34" charset="-122"/>
+                <a:cs typeface="Calibri" pitchFamily="34" charset="-120"/>
+              </a:rPr>
+              <a:t>Webhooks fraude — déclenchement auto à la détection</a:t>
+            </a:r>
+            <a:endParaRPr lang="en-US" sz="1100" dirty="0"/>
+          </a:p>
+        </p:txBody>
+      </p:sp>
+      <p:sp>
+        <p:nvSpPr>
+          <p:cNvPr id="13" name="Shape 11"/>
+          <p:cNvSpPr/>
+          <p:nvPr/>
+        </p:nvSpPr>
+        <p:spPr>
+          <a:xfrm>
+            <a:off x="502920" y="3813048"/>
+            <a:ext cx="256032" cy="256032"/>
+          </a:xfrm>
+          <a:prstGeom prst="ellipse">
+            <a:avLst/>
+          </a:prstGeom>
+          <a:solidFill>
+            <a:srgbClr val="10B981"/>
+          </a:solidFill>
+          <a:ln w="12700">
+            <a:solidFill>
+              <a:srgbClr val="10B981"/>
+            </a:solidFill>
+            <a:prstDash val="solid"/>
+          </a:ln>
+        </p:spPr>
+      </p:sp>
+      <p:sp>
+        <p:nvSpPr>
+          <p:cNvPr id="14" name="Text 12"/>
+          <p:cNvSpPr/>
+          <p:nvPr/>
+        </p:nvSpPr>
+        <p:spPr>
+          <a:xfrm>
+            <a:off x="850392" y="3739896"/>
+            <a:ext cx="2148840" cy="457200"/>
+          </a:xfrm>
+          <a:prstGeom prst="rect">
+            <a:avLst/>
+          </a:prstGeom>
+          <a:noFill/>
+          <a:ln/>
+        </p:spPr>
+        <p:txBody>
+          <a:bodyPr wrap="square" lIns="0" tIns="0" rIns="0" bIns="0" rtlCol="0" anchor="ctr"/>
+          <a:lstStyle/>
+          <a:p>
+            <a:pPr indent="0" marL="0">
+              <a:buNone/>
+            </a:pPr>
+            <a:r>
+              <a:rPr lang="en-US" sz="1100" dirty="0">
+                <a:solidFill>
+                  <a:srgbClr val="1E3A5F"/>
+                </a:solidFill>
+                <a:latin typeface="Calibri" pitchFamily="34" charset="0"/>
+                <a:ea typeface="Calibri" pitchFamily="34" charset="-122"/>
+                <a:cs typeface="Calibri" pitchFamily="34" charset="-120"/>
+              </a:rPr>
+              <a:t>Notifications SSE temps réel (bell + badge)</a:t>
+            </a:r>
+            <a:endParaRPr lang="en-US" sz="1100" dirty="0"/>
+          </a:p>
+        </p:txBody>
+      </p:sp>
+      <p:sp>
+        <p:nvSpPr>
+          <p:cNvPr id="15" name="Shape 13"/>
+          <p:cNvSpPr/>
+          <p:nvPr/>
+        </p:nvSpPr>
+        <p:spPr>
+          <a:xfrm>
+            <a:off x="502920" y="4379976"/>
+            <a:ext cx="256032" cy="256032"/>
+          </a:xfrm>
+          <a:prstGeom prst="ellipse">
+            <a:avLst/>
+          </a:prstGeom>
+          <a:solidFill>
+            <a:srgbClr val="10B981"/>
+          </a:solidFill>
+          <a:ln w="12700">
+            <a:solidFill>
+              <a:srgbClr val="10B981"/>
+            </a:solidFill>
+            <a:prstDash val="solid"/>
+          </a:ln>
+        </p:spPr>
+      </p:sp>
+      <p:sp>
+        <p:nvSpPr>
+          <p:cNvPr id="16" name="Text 14"/>
+          <p:cNvSpPr/>
+          <p:nvPr/>
+        </p:nvSpPr>
+        <p:spPr>
+          <a:xfrm>
+            <a:off x="850392" y="4306824"/>
+            <a:ext cx="2148840" cy="457200"/>
+          </a:xfrm>
+          <a:prstGeom prst="rect">
+            <a:avLst/>
+          </a:prstGeom>
+          <a:noFill/>
+          <a:ln/>
+        </p:spPr>
+        <p:txBody>
+          <a:bodyPr wrap="square" lIns="0" tIns="0" rIns="0" bIns="0" rtlCol="0" anchor="ctr"/>
+          <a:lstStyle/>
+          <a:p>
+            <a:pPr indent="0" marL="0">
+              <a:buNone/>
+            </a:pPr>
+            <a:r>
+              <a:rPr lang="en-US" sz="1100" dirty="0">
+                <a:solidFill>
+                  <a:srgbClr val="1E3A5F"/>
+                </a:solidFill>
+                <a:latin typeface="Calibri" pitchFamily="34" charset="0"/>
+                <a:ea typeface="Calibri" pitchFamily="34" charset="-122"/>
+                <a:cs typeface="Calibri" pitchFamily="34" charset="-120"/>
+              </a:rPr>
+              <a:t>Dark mode &amp; portail conformité export</a:t>
+            </a:r>
+            <a:endParaRPr lang="en-US" sz="1100" dirty="0"/>
+          </a:p>
+        </p:txBody>
+      </p:sp>
+      <p:sp>
+        <p:nvSpPr>
+          <p:cNvPr id="17" name="Shape 15"/>
+          <p:cNvSpPr/>
+          <p:nvPr/>
+        </p:nvSpPr>
+        <p:spPr>
+          <a:xfrm>
+            <a:off x="3721608" y="1417320"/>
+            <a:ext cx="1828800" cy="347472"/>
+          </a:xfrm>
+          <a:prstGeom prst="rect">
+            <a:avLst>
+              <a:gd name="adj" fmla="val 26316"/>
+            </a:avLst>
+          </a:prstGeom>
+          <a:solidFill>
             <a:srgbClr val="0EA5E9"/>
           </a:solidFill>
           <a:ln w="12700">
@@ -10867,13 +11262,13 @@
       </p:sp>
       <p:sp>
         <p:nvSpPr>
-          <p:cNvPr id="6" name="Text 4"/>
-          <p:cNvSpPr/>
-          <p:nvPr/>
-        </p:nvSpPr>
-        <p:spPr>
-          <a:xfrm>
-            <a:off x="777240" y="1417320"/>
+          <p:cNvPr id="18" name="Text 16"/>
+          <p:cNvSpPr/>
+          <p:nvPr/>
+        </p:nvSpPr>
+        <p:spPr>
+          <a:xfrm>
+            <a:off x="3721608" y="1417320"/>
             <a:ext cx="1828800" cy="347472"/>
           </a:xfrm>
           <a:prstGeom prst="rect">
@@ -10906,13 +11301,13 @@
       </p:sp>
       <p:sp>
         <p:nvSpPr>
-          <p:cNvPr id="7" name="Text 5"/>
-          <p:cNvSpPr/>
-          <p:nvPr/>
-        </p:nvSpPr>
-        <p:spPr>
-          <a:xfrm>
-            <a:off x="320040" y="1874520"/>
+          <p:cNvPr id="19" name="Text 17"/>
+          <p:cNvSpPr/>
+          <p:nvPr/>
+        </p:nvSpPr>
+        <p:spPr>
+          <a:xfrm>
+            <a:off x="3264408" y="1874520"/>
             <a:ext cx="2743200" cy="475488"/>
           </a:xfrm>
           <a:prstGeom prst="rect">
@@ -10945,13 +11340,13 @@
       </p:sp>
       <p:sp>
         <p:nvSpPr>
-          <p:cNvPr id="8" name="Shape 6"/>
-          <p:cNvSpPr/>
-          <p:nvPr/>
-        </p:nvSpPr>
-        <p:spPr>
-          <a:xfrm>
-            <a:off x="320040" y="2450592"/>
+          <p:cNvPr id="20" name="Shape 18"/>
+          <p:cNvSpPr/>
+          <p:nvPr/>
+        </p:nvSpPr>
+        <p:spPr>
+          <a:xfrm>
+            <a:off x="3264408" y="2450592"/>
             <a:ext cx="2788920" cy="2514600"/>
           </a:xfrm>
           <a:prstGeom prst="rect">
@@ -10979,13 +11374,13 @@
       </p:sp>
       <p:sp>
         <p:nvSpPr>
-          <p:cNvPr id="9" name="Shape 7"/>
-          <p:cNvSpPr/>
-          <p:nvPr/>
-        </p:nvSpPr>
-        <p:spPr>
-          <a:xfrm>
-            <a:off x="502920" y="2679192"/>
+          <p:cNvPr id="21" name="Shape 19"/>
+          <p:cNvSpPr/>
+          <p:nvPr/>
+        </p:nvSpPr>
+        <p:spPr>
+          <a:xfrm>
+            <a:off x="3447288" y="2679192"/>
             <a:ext cx="256032" cy="256032"/>
           </a:xfrm>
           <a:prstGeom prst="ellipse">
@@ -11004,13 +11399,13 @@
       </p:sp>
       <p:sp>
         <p:nvSpPr>
-          <p:cNvPr id="10" name="Text 8"/>
-          <p:cNvSpPr/>
-          <p:nvPr/>
-        </p:nvSpPr>
-        <p:spPr>
-          <a:xfrm>
-            <a:off x="850392" y="2606040"/>
+          <p:cNvPr id="22" name="Text 20"/>
+          <p:cNvSpPr/>
+          <p:nvPr/>
+        </p:nvSpPr>
+        <p:spPr>
+          <a:xfrm>
+            <a:off x="3794760" y="2606040"/>
             <a:ext cx="2148840" cy="457200"/>
           </a:xfrm>
           <a:prstGeom prst="rect">
@@ -11035,7 +11430,7 @@
                 <a:ea typeface="Calibri" pitchFamily="34" charset="-122"/>
                 <a:cs typeface="Calibri" pitchFamily="34" charset="-120"/>
               </a:rPr>
-              <a:t>Tableau de bord enrichi — KPIs réels &amp; graphiques avancés</a:t>
+              <a:t>API Keys — UI génération &amp; révocation</a:t>
             </a:r>
             <a:endParaRPr lang="en-US" sz="1100" dirty="0"/>
           </a:p>
@@ -11043,13 +11438,13 @@
       </p:sp>
       <p:sp>
         <p:nvSpPr>
-          <p:cNvPr id="11" name="Shape 9"/>
-          <p:cNvSpPr/>
-          <p:nvPr/>
-        </p:nvSpPr>
-        <p:spPr>
-          <a:xfrm>
-            <a:off x="502920" y="3246120"/>
+          <p:cNvPr id="23" name="Shape 21"/>
+          <p:cNvSpPr/>
+          <p:nvPr/>
+        </p:nvSpPr>
+        <p:spPr>
+          <a:xfrm>
+            <a:off x="3447288" y="3246120"/>
             <a:ext cx="256032" cy="256032"/>
           </a:xfrm>
           <a:prstGeom prst="ellipse">
@@ -11068,13 +11463,13 @@
       </p:sp>
       <p:sp>
         <p:nvSpPr>
-          <p:cNvPr id="12" name="Text 10"/>
-          <p:cNvSpPr/>
-          <p:nvPr/>
-        </p:nvSpPr>
-        <p:spPr>
-          <a:xfrm>
-            <a:off x="850392" y="3172968"/>
+          <p:cNvPr id="24" name="Text 22"/>
+          <p:cNvSpPr/>
+          <p:nvPr/>
+        </p:nvSpPr>
+        <p:spPr>
+          <a:xfrm>
+            <a:off x="3794760" y="3172968"/>
             <a:ext cx="2148840" cy="457200"/>
           </a:xfrm>
           <a:prstGeom prst="rect">
@@ -11099,7 +11494,7 @@
                 <a:ea typeface="Calibri" pitchFamily="34" charset="-122"/>
                 <a:cs typeface="Calibri" pitchFamily="34" charset="-120"/>
               </a:rPr>
-              <a:t>Webhooks fraude — déclenchement auto à la détection</a:t>
+              <a:t>Dashboard multi-tenant comparatif (admin)</a:t>
             </a:r>
             <a:endParaRPr lang="en-US" sz="1100" dirty="0"/>
           </a:p>
@@ -11107,13 +11502,13 @@
       </p:sp>
       <p:sp>
         <p:nvSpPr>
-          <p:cNvPr id="13" name="Shape 11"/>
-          <p:cNvSpPr/>
-          <p:nvPr/>
-        </p:nvSpPr>
-        <p:spPr>
-          <a:xfrm>
-            <a:off x="502920" y="3813048"/>
+          <p:cNvPr id="25" name="Shape 23"/>
+          <p:cNvSpPr/>
+          <p:nvPr/>
+        </p:nvSpPr>
+        <p:spPr>
+          <a:xfrm>
+            <a:off x="3447288" y="3813048"/>
             <a:ext cx="256032" cy="256032"/>
           </a:xfrm>
           <a:prstGeom prst="ellipse">
@@ -11132,13 +11527,13 @@
       </p:sp>
       <p:sp>
         <p:nvSpPr>
-          <p:cNvPr id="14" name="Text 12"/>
-          <p:cNvSpPr/>
-          <p:nvPr/>
-        </p:nvSpPr>
-        <p:spPr>
-          <a:xfrm>
-            <a:off x="850392" y="3739896"/>
+          <p:cNvPr id="26" name="Text 24"/>
+          <p:cNvSpPr/>
+          <p:nvPr/>
+        </p:nvSpPr>
+        <p:spPr>
+          <a:xfrm>
+            <a:off x="3794760" y="3739896"/>
             <a:ext cx="2148840" cy="457200"/>
           </a:xfrm>
           <a:prstGeom prst="rect">
@@ -11163,7 +11558,7 @@
                 <a:ea typeface="Calibri" pitchFamily="34" charset="-122"/>
                 <a:cs typeface="Calibri" pitchFamily="34" charset="-120"/>
               </a:rPr>
-              <a:t>API Keys — UI génération &amp; révocation (modèle existant)</a:t>
+              <a:t>Pages 404 / 500 personnalisées</a:t>
             </a:r>
             <a:endParaRPr lang="en-US" sz="1100" dirty="0"/>
           </a:p>
@@ -11171,13 +11566,13 @@
       </p:sp>
       <p:sp>
         <p:nvSpPr>
-          <p:cNvPr id="15" name="Shape 13"/>
-          <p:cNvSpPr/>
-          <p:nvPr/>
-        </p:nvSpPr>
-        <p:spPr>
-          <a:xfrm>
-            <a:off x="502920" y="4379976"/>
+          <p:cNvPr id="27" name="Shape 25"/>
+          <p:cNvSpPr/>
+          <p:nvPr/>
+        </p:nvSpPr>
+        <p:spPr>
+          <a:xfrm>
+            <a:off x="3447288" y="4379976"/>
             <a:ext cx="256032" cy="256032"/>
           </a:xfrm>
           <a:prstGeom prst="ellipse">
@@ -11196,13 +11591,13 @@
       </p:sp>
       <p:sp>
         <p:nvSpPr>
-          <p:cNvPr id="16" name="Text 14"/>
-          <p:cNvSpPr/>
-          <p:nvPr/>
-        </p:nvSpPr>
-        <p:spPr>
-          <a:xfrm>
-            <a:off x="850392" y="4306824"/>
+          <p:cNvPr id="28" name="Text 26"/>
+          <p:cNvSpPr/>
+          <p:nvPr/>
+        </p:nvSpPr>
+        <p:spPr>
+          <a:xfrm>
+            <a:off x="3794760" y="4306824"/>
             <a:ext cx="2148840" cy="457200"/>
           </a:xfrm>
           <a:prstGeom prst="rect">
@@ -11227,7 +11622,7 @@
                 <a:ea typeface="Calibri" pitchFamily="34" charset="-122"/>
                 <a:cs typeface="Calibri" pitchFamily="34" charset="-120"/>
               </a:rPr>
-              <a:t>Pages 404/500 personnalisées</a:t>
+              <a:t>Explainabilité IA (SHAP values sur alertes)</a:t>
             </a:r>
             <a:endParaRPr lang="en-US" sz="1100" dirty="0"/>
           </a:p>
@@ -11235,13 +11630,13 @@
       </p:sp>
       <p:sp>
         <p:nvSpPr>
-          <p:cNvPr id="17" name="Shape 15"/>
-          <p:cNvSpPr/>
-          <p:nvPr/>
-        </p:nvSpPr>
-        <p:spPr>
-          <a:xfrm>
-            <a:off x="3721608" y="1417320"/>
+          <p:cNvPr id="29" name="Shape 27"/>
+          <p:cNvSpPr/>
+          <p:nvPr/>
+        </p:nvSpPr>
+        <p:spPr>
+          <a:xfrm>
+            <a:off x="6665976" y="1417320"/>
             <a:ext cx="1828800" cy="347472"/>
           </a:xfrm>
           <a:prstGeom prst="rect">
@@ -11262,13 +11657,13 @@
       </p:sp>
       <p:sp>
         <p:nvSpPr>
-          <p:cNvPr id="18" name="Text 16"/>
-          <p:cNvSpPr/>
-          <p:nvPr/>
-        </p:nvSpPr>
-        <p:spPr>
-          <a:xfrm>
-            <a:off x="3721608" y="1417320"/>
+          <p:cNvPr id="30" name="Text 28"/>
+          <p:cNvSpPr/>
+          <p:nvPr/>
+        </p:nvSpPr>
+        <p:spPr>
+          <a:xfrm>
+            <a:off x="6665976" y="1417320"/>
             <a:ext cx="1828800" cy="347472"/>
           </a:xfrm>
           <a:prstGeom prst="rect">
@@ -11301,13 +11696,13 @@
       </p:sp>
       <p:sp>
         <p:nvSpPr>
-          <p:cNvPr id="19" name="Text 17"/>
-          <p:cNvSpPr/>
-          <p:nvPr/>
-        </p:nvSpPr>
-        <p:spPr>
-          <a:xfrm>
-            <a:off x="3264408" y="1874520"/>
+          <p:cNvPr id="31" name="Text 29"/>
+          <p:cNvSpPr/>
+          <p:nvPr/>
+        </p:nvSpPr>
+        <p:spPr>
+          <a:xfrm>
+            <a:off x="6208776" y="1874520"/>
             <a:ext cx="2743200" cy="475488"/>
           </a:xfrm>
           <a:prstGeom prst="rect">
@@ -11340,13 +11735,13 @@
       </p:sp>
       <p:sp>
         <p:nvSpPr>
-          <p:cNvPr id="20" name="Shape 18"/>
-          <p:cNvSpPr/>
-          <p:nvPr/>
-        </p:nvSpPr>
-        <p:spPr>
-          <a:xfrm>
-            <a:off x="3264408" y="2450592"/>
+          <p:cNvPr id="32" name="Shape 30"/>
+          <p:cNvSpPr/>
+          <p:nvPr/>
+        </p:nvSpPr>
+        <p:spPr>
+          <a:xfrm>
+            <a:off x="6208776" y="2450592"/>
             <a:ext cx="2788920" cy="2514600"/>
           </a:xfrm>
           <a:prstGeom prst="rect">
@@ -11374,13 +11769,13 @@
       </p:sp>
       <p:sp>
         <p:nvSpPr>
-          <p:cNvPr id="21" name="Shape 19"/>
-          <p:cNvSpPr/>
-          <p:nvPr/>
-        </p:nvSpPr>
-        <p:spPr>
-          <a:xfrm>
-            <a:off x="3447288" y="2679192"/>
+          <p:cNvPr id="33" name="Shape 31"/>
+          <p:cNvSpPr/>
+          <p:nvPr/>
+        </p:nvSpPr>
+        <p:spPr>
+          <a:xfrm>
+            <a:off x="6391656" y="2679192"/>
             <a:ext cx="256032" cy="256032"/>
           </a:xfrm>
           <a:prstGeom prst="ellipse">
@@ -11399,13 +11794,13 @@
       </p:sp>
       <p:sp>
         <p:nvSpPr>
-          <p:cNvPr id="22" name="Text 20"/>
-          <p:cNvSpPr/>
-          <p:nvPr/>
-        </p:nvSpPr>
-        <p:spPr>
-          <a:xfrm>
-            <a:off x="3794760" y="2606040"/>
+          <p:cNvPr id="34" name="Text 32"/>
+          <p:cNvSpPr/>
+          <p:nvPr/>
+        </p:nvSpPr>
+        <p:spPr>
+          <a:xfrm>
+            <a:off x="6739128" y="2606040"/>
             <a:ext cx="2148840" cy="457200"/>
           </a:xfrm>
           <a:prstGeom prst="rect">
@@ -11430,7 +11825,7 @@
                 <a:ea typeface="Calibri" pitchFamily="34" charset="-122"/>
                 <a:cs typeface="Calibri" pitchFamily="34" charset="-120"/>
               </a:rPr>
-              <a:t>Dashboard comparatif multi-tenant (admin)</a:t>
+              <a:t>Modèle IA v2 (XGBoost + ensemble)</a:t>
             </a:r>
             <a:endParaRPr lang="en-US" sz="1100" dirty="0"/>
           </a:p>
@@ -11438,13 +11833,13 @@
       </p:sp>
       <p:sp>
         <p:nvSpPr>
-          <p:cNvPr id="23" name="Shape 21"/>
-          <p:cNvSpPr/>
-          <p:nvPr/>
-        </p:nvSpPr>
-        <p:spPr>
-          <a:xfrm>
-            <a:off x="3447288" y="3246120"/>
+          <p:cNvPr id="35" name="Shape 33"/>
+          <p:cNvSpPr/>
+          <p:nvPr/>
+        </p:nvSpPr>
+        <p:spPr>
+          <a:xfrm>
+            <a:off x="6391656" y="3246120"/>
             <a:ext cx="256032" cy="256032"/>
           </a:xfrm>
           <a:prstGeom prst="ellipse">
@@ -11463,13 +11858,13 @@
       </p:sp>
       <p:sp>
         <p:nvSpPr>
-          <p:cNvPr id="24" name="Text 22"/>
-          <p:cNvSpPr/>
-          <p:nvPr/>
-        </p:nvSpPr>
-        <p:spPr>
-          <a:xfrm>
-            <a:off x="3794760" y="3172968"/>
+          <p:cNvPr id="36" name="Text 34"/>
+          <p:cNvSpPr/>
+          <p:nvPr/>
+        </p:nvSpPr>
+        <p:spPr>
+          <a:xfrm>
+            <a:off x="6739128" y="3172968"/>
             <a:ext cx="2148840" cy="457200"/>
           </a:xfrm>
           <a:prstGeom prst="rect">
@@ -11494,7 +11889,7 @@
                 <a:ea typeface="Calibri" pitchFamily="34" charset="-122"/>
                 <a:cs typeface="Calibri" pitchFamily="34" charset="-120"/>
               </a:rPr>
-              <a:t>Modèle IA v2 (XGBoost + ensemble)</a:t>
+              <a:t>Intégration SWIFT GPI cross-border</a:t>
             </a:r>
             <a:endParaRPr lang="en-US" sz="1100" dirty="0"/>
           </a:p>
@@ -11502,13 +11897,13 @@
       </p:sp>
       <p:sp>
         <p:nvSpPr>
-          <p:cNvPr id="25" name="Shape 23"/>
-          <p:cNvSpPr/>
-          <p:nvPr/>
-        </p:nvSpPr>
-        <p:spPr>
-          <a:xfrm>
-            <a:off x="3447288" y="3813048"/>
+          <p:cNvPr id="37" name="Shape 35"/>
+          <p:cNvSpPr/>
+          <p:nvPr/>
+        </p:nvSpPr>
+        <p:spPr>
+          <a:xfrm>
+            <a:off x="6391656" y="3813048"/>
             <a:ext cx="256032" cy="256032"/>
           </a:xfrm>
           <a:prstGeom prst="ellipse">
@@ -11527,13 +11922,13 @@
       </p:sp>
       <p:sp>
         <p:nvSpPr>
-          <p:cNvPr id="26" name="Text 24"/>
-          <p:cNvSpPr/>
-          <p:nvPr/>
-        </p:nvSpPr>
-        <p:spPr>
-          <a:xfrm>
-            <a:off x="3794760" y="3739896"/>
+          <p:cNvPr id="38" name="Text 36"/>
+          <p:cNvSpPr/>
+          <p:nvPr/>
+        </p:nvSpPr>
+        <p:spPr>
+          <a:xfrm>
+            <a:off x="6739128" y="3739896"/>
             <a:ext cx="2148840" cy="457200"/>
           </a:xfrm>
           <a:prstGeom prst="rect">
@@ -11558,7 +11953,7 @@
                 <a:ea typeface="Calibri" pitchFamily="34" charset="-122"/>
                 <a:cs typeface="Calibri" pitchFamily="34" charset="-120"/>
               </a:rPr>
-              <a:t>Intégration SWIFT GPI transactions cross-border</a:t>
+              <a:t>Application mobile (React Native)</a:t>
             </a:r>
             <a:endParaRPr lang="en-US" sz="1100" dirty="0"/>
           </a:p>
@@ -11566,13 +11961,13 @@
       </p:sp>
       <p:sp>
         <p:nvSpPr>
-          <p:cNvPr id="27" name="Shape 25"/>
-          <p:cNvSpPr/>
-          <p:nvPr/>
-        </p:nvSpPr>
-        <p:spPr>
-          <a:xfrm>
-            <a:off x="3447288" y="4379976"/>
+          <p:cNvPr id="39" name="Shape 37"/>
+          <p:cNvSpPr/>
+          <p:nvPr/>
+        </p:nvSpPr>
+        <p:spPr>
+          <a:xfrm>
+            <a:off x="6391656" y="4379976"/>
             <a:ext cx="256032" cy="256032"/>
           </a:xfrm>
           <a:prstGeom prst="ellipse">
@@ -11591,13 +11986,13 @@
       </p:sp>
       <p:sp>
         <p:nvSpPr>
-          <p:cNvPr id="28" name="Text 26"/>
-          <p:cNvSpPr/>
-          <p:nvPr/>
-        </p:nvSpPr>
-        <p:spPr>
-          <a:xfrm>
-            <a:off x="3794760" y="4306824"/>
+          <p:cNvPr id="40" name="Text 38"/>
+          <p:cNvSpPr/>
+          <p:nvPr/>
+        </p:nvSpPr>
+        <p:spPr>
+          <a:xfrm>
+            <a:off x="6739128" y="4306824"/>
             <a:ext cx="2148840" cy="457200"/>
           </a:xfrm>
           <a:prstGeom prst="rect">
@@ -11622,402 +12017,7 @@
                 <a:ea typeface="Calibri" pitchFamily="34" charset="-122"/>
                 <a:cs typeface="Calibri" pitchFamily="34" charset="-120"/>
               </a:rPr>
-              <a:t>Application mobile (React Native)</a:t>
-            </a:r>
-            <a:endParaRPr lang="en-US" sz="1100" dirty="0"/>
-          </a:p>
-        </p:txBody>
-      </p:sp>
-      <p:sp>
-        <p:nvSpPr>
-          <p:cNvPr id="29" name="Shape 27"/>
-          <p:cNvSpPr/>
-          <p:nvPr/>
-        </p:nvSpPr>
-        <p:spPr>
-          <a:xfrm>
-            <a:off x="6665976" y="1417320"/>
-            <a:ext cx="1828800" cy="347472"/>
-          </a:xfrm>
-          <a:prstGeom prst="rect">
-            <a:avLst>
-              <a:gd name="adj" fmla="val 26316"/>
-            </a:avLst>
-          </a:prstGeom>
-          <a:solidFill>
-            <a:srgbClr val="10B981"/>
-          </a:solidFill>
-          <a:ln w="12700">
-            <a:solidFill>
-              <a:srgbClr val="10B981"/>
-            </a:solidFill>
-            <a:prstDash val="solid"/>
-          </a:ln>
-        </p:spPr>
-      </p:sp>
-      <p:sp>
-        <p:nvSpPr>
-          <p:cNvPr id="30" name="Text 28"/>
-          <p:cNvSpPr/>
-          <p:nvPr/>
-        </p:nvSpPr>
-        <p:spPr>
-          <a:xfrm>
-            <a:off x="6665976" y="1417320"/>
-            <a:ext cx="1828800" cy="347472"/>
-          </a:xfrm>
-          <a:prstGeom prst="rect">
-            <a:avLst/>
-          </a:prstGeom>
-          <a:noFill/>
-          <a:ln/>
-        </p:spPr>
-        <p:txBody>
-          <a:bodyPr wrap="square" lIns="0" tIns="0" rIns="0" bIns="0" rtlCol="0" anchor="ctr"/>
-          <a:lstStyle/>
-          <a:p>
-            <a:pPr algn="ctr" indent="0" marL="0">
-              <a:buNone/>
-            </a:pPr>
-            <a:r>
-              <a:rPr lang="en-US" sz="1100" b="1" dirty="0">
-                <a:solidFill>
-                  <a:srgbClr val="FFFFFF"/>
-                </a:solidFill>
-                <a:latin typeface="Calibri" pitchFamily="34" charset="0"/>
-                <a:ea typeface="Calibri" pitchFamily="34" charset="-122"/>
-                <a:cs typeface="Calibri" pitchFamily="34" charset="-120"/>
-              </a:rPr>
-              <a:t>Vision</a:t>
-            </a:r>
-            <a:endParaRPr lang="en-US" sz="1100" dirty="0"/>
-          </a:p>
-        </p:txBody>
-      </p:sp>
-      <p:sp>
-        <p:nvSpPr>
-          <p:cNvPr id="31" name="Text 29"/>
-          <p:cNvSpPr/>
-          <p:nvPr/>
-        </p:nvSpPr>
-        <p:spPr>
-          <a:xfrm>
-            <a:off x="6208776" y="1874520"/>
-            <a:ext cx="2743200" cy="475488"/>
-          </a:xfrm>
-          <a:prstGeom prst="rect">
-            <a:avLst/>
-          </a:prstGeom>
-          <a:noFill/>
-          <a:ln/>
-        </p:spPr>
-        <p:txBody>
-          <a:bodyPr wrap="square" lIns="0" tIns="0" rIns="0" bIns="0" rtlCol="0" anchor="ctr"/>
-          <a:lstStyle/>
-          <a:p>
-            <a:pPr algn="ctr" indent="0" marL="0">
-              <a:buNone/>
-            </a:pPr>
-            <a:r>
-              <a:rPr lang="en-US" sz="2800" b="1" dirty="0">
-                <a:solidFill>
-                  <a:srgbClr val="10B981"/>
-                </a:solidFill>
-                <a:latin typeface="Cambria" pitchFamily="34" charset="0"/>
-                <a:ea typeface="Cambria" pitchFamily="34" charset="-122"/>
-                <a:cs typeface="Cambria" pitchFamily="34" charset="-120"/>
-              </a:rPr>
-              <a:t>2027</a:t>
-            </a:r>
-            <a:endParaRPr lang="en-US" sz="2800" dirty="0"/>
-          </a:p>
-        </p:txBody>
-      </p:sp>
-      <p:sp>
-        <p:nvSpPr>
-          <p:cNvPr id="32" name="Shape 30"/>
-          <p:cNvSpPr/>
-          <p:nvPr/>
-        </p:nvSpPr>
-        <p:spPr>
-          <a:xfrm>
-            <a:off x="6208776" y="2450592"/>
-            <a:ext cx="2788920" cy="2514600"/>
-          </a:xfrm>
-          <a:prstGeom prst="rect">
-            <a:avLst>
-              <a:gd name="adj" fmla="val 3636"/>
-            </a:avLst>
-          </a:prstGeom>
-          <a:solidFill>
-            <a:srgbClr val="FFFFFF"/>
-          </a:solidFill>
-          <a:ln w="12700">
-            <a:solidFill>
-              <a:srgbClr val="10B981"/>
-            </a:solidFill>
-            <a:prstDash val="solid"/>
-          </a:ln>
-          <a:effectLst>
-            <a:outerShdw sx="100000" sy="100000" kx="0" ky="0" algn="bl" rotWithShape="0" blurRad="101600" dist="38100" dir="2700000">
-              <a:srgbClr val="000000">
-                <a:alpha val="12000"/>
-              </a:srgbClr>
-            </a:outerShdw>
-          </a:effectLst>
-        </p:spPr>
-      </p:sp>
-      <p:sp>
-        <p:nvSpPr>
-          <p:cNvPr id="33" name="Shape 31"/>
-          <p:cNvSpPr/>
-          <p:nvPr/>
-        </p:nvSpPr>
-        <p:spPr>
-          <a:xfrm>
-            <a:off x="6391656" y="2679192"/>
-            <a:ext cx="256032" cy="256032"/>
-          </a:xfrm>
-          <a:prstGeom prst="ellipse">
-            <a:avLst/>
-          </a:prstGeom>
-          <a:solidFill>
-            <a:srgbClr val="10B981"/>
-          </a:solidFill>
-          <a:ln w="12700">
-            <a:solidFill>
-              <a:srgbClr val="10B981"/>
-            </a:solidFill>
-            <a:prstDash val="solid"/>
-          </a:ln>
-        </p:spPr>
-      </p:sp>
-      <p:sp>
-        <p:nvSpPr>
-          <p:cNvPr id="34" name="Text 32"/>
-          <p:cNvSpPr/>
-          <p:nvPr/>
-        </p:nvSpPr>
-        <p:spPr>
-          <a:xfrm>
-            <a:off x="6739128" y="2606040"/>
-            <a:ext cx="2148840" cy="457200"/>
-          </a:xfrm>
-          <a:prstGeom prst="rect">
-            <a:avLst/>
-          </a:prstGeom>
-          <a:noFill/>
-          <a:ln/>
-        </p:spPr>
-        <p:txBody>
-          <a:bodyPr wrap="square" lIns="0" tIns="0" rIns="0" bIns="0" rtlCol="0" anchor="ctr"/>
-          <a:lstStyle/>
-          <a:p>
-            <a:pPr indent="0" marL="0">
-              <a:buNone/>
-            </a:pPr>
-            <a:r>
-              <a:rPr lang="en-US" sz="1100" dirty="0">
-                <a:solidFill>
-                  <a:srgbClr val="1E3A5F"/>
-                </a:solidFill>
-                <a:latin typeface="Calibri" pitchFamily="34" charset="0"/>
-                <a:ea typeface="Calibri" pitchFamily="34" charset="-122"/>
-                <a:cs typeface="Calibri" pitchFamily="34" charset="-120"/>
-              </a:rPr>
-              <a:t>Explainabilité IA (SHAP values sur alertes)</a:t>
-            </a:r>
-            <a:endParaRPr lang="en-US" sz="1100" dirty="0"/>
-          </a:p>
-        </p:txBody>
-      </p:sp>
-      <p:sp>
-        <p:nvSpPr>
-          <p:cNvPr id="35" name="Shape 33"/>
-          <p:cNvSpPr/>
-          <p:nvPr/>
-        </p:nvSpPr>
-        <p:spPr>
-          <a:xfrm>
-            <a:off x="6391656" y="3246120"/>
-            <a:ext cx="256032" cy="256032"/>
-          </a:xfrm>
-          <a:prstGeom prst="ellipse">
-            <a:avLst/>
-          </a:prstGeom>
-          <a:solidFill>
-            <a:srgbClr val="10B981"/>
-          </a:solidFill>
-          <a:ln w="12700">
-            <a:solidFill>
-              <a:srgbClr val="10B981"/>
-            </a:solidFill>
-            <a:prstDash val="solid"/>
-          </a:ln>
-        </p:spPr>
-      </p:sp>
-      <p:sp>
-        <p:nvSpPr>
-          <p:cNvPr id="36" name="Text 34"/>
-          <p:cNvSpPr/>
-          <p:nvPr/>
-        </p:nvSpPr>
-        <p:spPr>
-          <a:xfrm>
-            <a:off x="6739128" y="3172968"/>
-            <a:ext cx="2148840" cy="457200"/>
-          </a:xfrm>
-          <a:prstGeom prst="rect">
-            <a:avLst/>
-          </a:prstGeom>
-          <a:noFill/>
-          <a:ln/>
-        </p:spPr>
-        <p:txBody>
-          <a:bodyPr wrap="square" lIns="0" tIns="0" rIns="0" bIns="0" rtlCol="0" anchor="ctr"/>
-          <a:lstStyle/>
-          <a:p>
-            <a:pPr indent="0" marL="0">
-              <a:buNone/>
-            </a:pPr>
-            <a:r>
-              <a:rPr lang="en-US" sz="1100" dirty="0">
-                <a:solidFill>
-                  <a:srgbClr val="1E3A5F"/>
-                </a:solidFill>
-                <a:latin typeface="Calibri" pitchFamily="34" charset="0"/>
-                <a:ea typeface="Calibri" pitchFamily="34" charset="-122"/>
-                <a:cs typeface="Calibri" pitchFamily="34" charset="-120"/>
-              </a:rPr>
-              <a:t>Détection réseau de fraude (graphe)</a:t>
-            </a:r>
-            <a:endParaRPr lang="en-US" sz="1100" dirty="0"/>
-          </a:p>
-        </p:txBody>
-      </p:sp>
-      <p:sp>
-        <p:nvSpPr>
-          <p:cNvPr id="37" name="Shape 35"/>
-          <p:cNvSpPr/>
-          <p:nvPr/>
-        </p:nvSpPr>
-        <p:spPr>
-          <a:xfrm>
-            <a:off x="6391656" y="3813048"/>
-            <a:ext cx="256032" cy="256032"/>
-          </a:xfrm>
-          <a:prstGeom prst="ellipse">
-            <a:avLst/>
-          </a:prstGeom>
-          <a:solidFill>
-            <a:srgbClr val="10B981"/>
-          </a:solidFill>
-          <a:ln w="12700">
-            <a:solidFill>
-              <a:srgbClr val="10B981"/>
-            </a:solidFill>
-            <a:prstDash val="solid"/>
-          </a:ln>
-        </p:spPr>
-      </p:sp>
-      <p:sp>
-        <p:nvSpPr>
-          <p:cNvPr id="38" name="Text 36"/>
-          <p:cNvSpPr/>
-          <p:nvPr/>
-        </p:nvSpPr>
-        <p:spPr>
-          <a:xfrm>
-            <a:off x="6739128" y="3739896"/>
-            <a:ext cx="2148840" cy="457200"/>
-          </a:xfrm>
-          <a:prstGeom prst="rect">
-            <a:avLst/>
-          </a:prstGeom>
-          <a:noFill/>
-          <a:ln/>
-        </p:spPr>
-        <p:txBody>
-          <a:bodyPr wrap="square" lIns="0" tIns="0" rIns="0" bIns="0" rtlCol="0" anchor="ctr"/>
-          <a:lstStyle/>
-          <a:p>
-            <a:pPr indent="0" marL="0">
-              <a:buNone/>
-            </a:pPr>
-            <a:r>
-              <a:rPr lang="en-US" sz="1100" dirty="0">
-                <a:solidFill>
-                  <a:srgbClr val="1E3A5F"/>
-                </a:solidFill>
-                <a:latin typeface="Calibri" pitchFamily="34" charset="0"/>
-                <a:ea typeface="Calibri" pitchFamily="34" charset="-122"/>
-                <a:cs typeface="Calibri" pitchFamily="34" charset="-120"/>
-              </a:rPr>
-              <a:t>Certification ISO 27001</a:t>
-            </a:r>
-            <a:endParaRPr lang="en-US" sz="1100" dirty="0"/>
-          </a:p>
-        </p:txBody>
-      </p:sp>
-      <p:sp>
-        <p:nvSpPr>
-          <p:cNvPr id="39" name="Shape 37"/>
-          <p:cNvSpPr/>
-          <p:nvPr/>
-        </p:nvSpPr>
-        <p:spPr>
-          <a:xfrm>
-            <a:off x="6391656" y="4379976"/>
-            <a:ext cx="256032" cy="256032"/>
-          </a:xfrm>
-          <a:prstGeom prst="ellipse">
-            <a:avLst/>
-          </a:prstGeom>
-          <a:solidFill>
-            <a:srgbClr val="10B981"/>
-          </a:solidFill>
-          <a:ln w="12700">
-            <a:solidFill>
-              <a:srgbClr val="10B981"/>
-            </a:solidFill>
-            <a:prstDash val="solid"/>
-          </a:ln>
-        </p:spPr>
-      </p:sp>
-      <p:sp>
-        <p:nvSpPr>
-          <p:cNvPr id="40" name="Text 38"/>
-          <p:cNvSpPr/>
-          <p:nvPr/>
-        </p:nvSpPr>
-        <p:spPr>
-          <a:xfrm>
-            <a:off x="6739128" y="4306824"/>
-            <a:ext cx="2148840" cy="457200"/>
-          </a:xfrm>
-          <a:prstGeom prst="rect">
-            <a:avLst/>
-          </a:prstGeom>
-          <a:noFill/>
-          <a:ln/>
-        </p:spPr>
-        <p:txBody>
-          <a:bodyPr wrap="square" lIns="0" tIns="0" rIns="0" bIns="0" rtlCol="0" anchor="ctr"/>
-          <a:lstStyle/>
-          <a:p>
-            <a:pPr indent="0" marL="0">
-              <a:buNone/>
-            </a:pPr>
-            <a:r>
-              <a:rPr lang="en-US" sz="1100" dirty="0">
-                <a:solidFill>
-                  <a:srgbClr val="1E3A5F"/>
-                </a:solidFill>
-                <a:latin typeface="Calibri" pitchFamily="34" charset="0"/>
-                <a:ea typeface="Calibri" pitchFamily="34" charset="-122"/>
-                <a:cs typeface="Calibri" pitchFamily="34" charset="-120"/>
-              </a:rPr>
-              <a:t>Déploiement cloud multi-région UEMOA</a:t>
+              <a:t>Certification ISO 27001 &amp; déploiement UEMOA</a:t>
             </a:r>
             <a:endParaRPr lang="en-US" sz="1100" dirty="0"/>
           </a:p>

</xml_diff>